<commit_message>
feat: slides atualizados (LISA por permutação, validação GeoDa) + versão PDF
- números novos: roubo 45 AA + campo Baixo-Baixo; furto 36% litorâneos no AA
- bullet de validação cruzada R x GeoDa nos resultados e conclusões
- slides/apresentacao.pdf: 10 páginas no tema claro, layout fiel ao deck
</commit_message>
<xml_diff>
--- a/slides/apresentacao.pptx
+++ b/slides/apresentacao.pptx
@@ -3677,7 +3677,7 @@
         <p:spPr>
           <a:xfrm>
             <a:off x="822960" y="1828800"/>
-            <a:ext cx="9875520" cy="2377440"/>
+            <a:ext cx="9875520" cy="2468880"/>
           </a:xfrm>
           <a:prstGeom prst="rect">
             <a:avLst/>
@@ -3726,7 +3726,7 @@
           <a:p>
             <a:pPr algn="l">
               <a:spcBef>
-                <a:spcPts val="1300"/>
+                <a:spcPts val="1200"/>
               </a:spcBef>
             </a:pPr>
             <a:r>
@@ -3760,7 +3760,7 @@
           <a:p>
             <a:pPr algn="l">
               <a:spcBef>
-                <a:spcPts val="1300"/>
+                <a:spcPts val="1200"/>
               </a:spcBef>
             </a:pPr>
             <a:r>
@@ -3798,6 +3798,40 @@
                 <a:latin typeface="Georgia"/>
               </a:rPr>
               <a:t> — em cidades turísticas isso superestima o risco real. É limitação central a discutir no texto final.</a:t>
+            </a:r>
+          </a:p>
+          <a:p>
+            <a:pPr algn="l">
+              <a:spcBef>
+                <a:spcPts val="1200"/>
+              </a:spcBef>
+            </a:pPr>
+            <a:r>
+              <a:rPr sz="1200" b="0" i="0">
+                <a:solidFill>
+                  <a:srgbClr val="0B5394"/>
+                </a:solidFill>
+                <a:latin typeface="Arial Narrow"/>
+              </a:rPr>
+              <a:t>■  </a:t>
+            </a:r>
+            <a:r>
+              <a:rPr sz="1500" b="1" i="0">
+                <a:solidFill>
+                  <a:srgbClr val="17222E"/>
+                </a:solidFill>
+                <a:latin typeface="Georgia"/>
+              </a:rPr>
+              <a:t>Experimentos no GeoDa concluídos e validados</a:t>
+            </a:r>
+            <a:r>
+              <a:rPr sz="1500" b="0" i="0">
+                <a:solidFill>
+                  <a:srgbClr val="17222E"/>
+                </a:solidFill>
+                <a:latin typeface="Georgia"/>
+              </a:rPr>
+              <a:t> contra o pipeline em R (mapas, Moran global e LISA) — ver docs/guia_geoda.md.</a:t>
             </a:r>
           </a:p>
         </p:txBody>
@@ -8534,7 +8568,7 @@
         <p:spPr>
           <a:xfrm>
             <a:off x="822960" y="3429000"/>
-            <a:ext cx="4937760" cy="2926080"/>
+            <a:ext cx="4937760" cy="3108960"/>
           </a:xfrm>
           <a:prstGeom prst="rect">
             <a:avLst/>
@@ -8553,7 +8587,7 @@
               </a:spcBef>
             </a:pPr>
             <a:r>
-              <a:rPr sz="1100" b="0" i="0">
+              <a:rPr sz="1000" b="0" i="0">
                 <a:solidFill>
                   <a:srgbClr val="0B5394"/>
                 </a:solidFill>
@@ -8562,23 +8596,23 @@
               <a:t>■  </a:t>
             </a:r>
             <a:r>
-              <a:rPr sz="1400" b="0" i="0">
-                <a:solidFill>
-                  <a:srgbClr val="17222E"/>
-                </a:solidFill>
-                <a:latin typeface="Georgia"/>
-              </a:rPr>
-              <a:t>Vizinhança queen, pesos row-standardized, 999 permutações.</a:t>
+              <a:rPr sz="1300" b="0" i="0">
+                <a:solidFill>
+                  <a:srgbClr val="17222E"/>
+                </a:solidFill>
+                <a:latin typeface="Georgia"/>
+              </a:rPr>
+              <a:t>Queen, pesos row-standardized, 999 permutações (LISA por permutação condicional, como no GeoDa).</a:t>
             </a:r>
           </a:p>
           <a:p>
             <a:pPr algn="l">
               <a:spcBef>
-                <a:spcPts val="1300"/>
+                <a:spcPts val="1100"/>
               </a:spcBef>
             </a:pPr>
             <a:r>
-              <a:rPr sz="1100" b="0" i="0">
+              <a:rPr sz="1000" b="0" i="0">
                 <a:solidFill>
                   <a:srgbClr val="0B5394"/>
                 </a:solidFill>
@@ -8587,7 +8621,7 @@
               <a:t>■  </a:t>
             </a:r>
             <a:r>
-              <a:rPr sz="1400" b="1" i="0">
+              <a:rPr sz="1300" b="1" i="0">
                 <a:solidFill>
                   <a:srgbClr val="17222E"/>
                 </a:solidFill>
@@ -8596,7 +8630,7 @@
               <a:t>Roubo</a:t>
             </a:r>
             <a:r>
-              <a:rPr sz="1400" b="0" i="0">
+              <a:rPr sz="1300" b="0" i="0">
                 <a:solidFill>
                   <a:srgbClr val="17222E"/>
                 </a:solidFill>
@@ -8605,7 +8639,7 @@
               <a:t>: um único grande cluster Alto-Alto — </a:t>
             </a:r>
             <a:r>
-              <a:rPr sz="1400" b="1" i="0">
+              <a:rPr sz="1300" b="1" i="0">
                 <a:solidFill>
                   <a:srgbClr val="17222E"/>
                 </a:solidFill>
@@ -8614,23 +8648,23 @@
               <a:t>RMSP + Baixada Santista</a:t>
             </a:r>
             <a:r>
-              <a:rPr sz="1400" b="0" i="0">
-                <a:solidFill>
-                  <a:srgbClr val="17222E"/>
-                </a:solidFill>
-                <a:latin typeface="Georgia"/>
-              </a:rPr>
-              <a:t> (53 municípios).</a:t>
+              <a:rPr sz="1300" b="0" i="0">
+                <a:solidFill>
+                  <a:srgbClr val="17222E"/>
+                </a:solidFill>
+                <a:latin typeface="Georgia"/>
+              </a:rPr>
+              <a:t> (45 municípios) — e extenso campo Baixo-Baixo no oeste.</a:t>
             </a:r>
           </a:p>
           <a:p>
             <a:pPr algn="l">
               <a:spcBef>
-                <a:spcPts val="1300"/>
+                <a:spcPts val="1100"/>
               </a:spcBef>
             </a:pPr>
             <a:r>
-              <a:rPr sz="1100" b="0" i="0">
+              <a:rPr sz="1000" b="0" i="0">
                 <a:solidFill>
                   <a:srgbClr val="B2182B"/>
                 </a:solidFill>
@@ -8639,7 +8673,7 @@
               <a:t>■  </a:t>
             </a:r>
             <a:r>
-              <a:rPr sz="1400" b="1" i="0">
+              <a:rPr sz="1300" b="1" i="0">
                 <a:solidFill>
                   <a:srgbClr val="17222E"/>
                 </a:solidFill>
@@ -8648,7 +8682,7 @@
               <a:t>Furto</a:t>
             </a:r>
             <a:r>
-              <a:rPr sz="1400" b="0" i="0">
+              <a:rPr sz="1300" b="0" i="0">
                 <a:solidFill>
                   <a:srgbClr val="17222E"/>
                 </a:solidFill>
@@ -8657,7 +8691,7 @@
               <a:t>: cluster Alto-Alto acompanha o </a:t>
             </a:r>
             <a:r>
-              <a:rPr sz="1400" b="1" i="0">
+              <a:rPr sz="1300" b="1" i="0">
                 <a:solidFill>
                   <a:srgbClr val="17222E"/>
                 </a:solidFill>
@@ -8666,13 +8700,13 @@
               <a:t>litoral</a:t>
             </a:r>
             <a:r>
-              <a:rPr sz="1400" b="0" i="0">
-                <a:solidFill>
-                  <a:srgbClr val="17222E"/>
-                </a:solidFill>
-                <a:latin typeface="Georgia"/>
-              </a:rPr>
-              <a:t> — 29% dos municípios do cluster são litorâneos/turísticos. </a:t>
+              <a:rPr sz="1300" b="0" i="0">
+                <a:solidFill>
+                  <a:srgbClr val="17222E"/>
+                </a:solidFill>
+                <a:latin typeface="Georgia"/>
+              </a:rPr>
+              <a:t> — 36% dos municípios do cluster são litorâneos/turísticos. </a:t>
             </a:r>
             <a:r>
               <a:rPr sz="1300" b="1" i="0">
@@ -8682,6 +8716,49 @@
                 <a:latin typeface="Arial Narrow"/>
               </a:rPr>
               <a:t>EVIDÊNCIA A FAVOR DA H2</a:t>
+            </a:r>
+          </a:p>
+          <a:p>
+            <a:pPr algn="l">
+              <a:spcBef>
+                <a:spcPts val="1100"/>
+              </a:spcBef>
+            </a:pPr>
+            <a:r>
+              <a:rPr sz="1000" b="0" i="0">
+                <a:solidFill>
+                  <a:srgbClr val="0B5394"/>
+                </a:solidFill>
+                <a:latin typeface="Arial Narrow"/>
+              </a:rPr>
+              <a:t>■  </a:t>
+            </a:r>
+            <a:r>
+              <a:rPr sz="1300" b="0" i="0">
+                <a:solidFill>
+                  <a:srgbClr val="17222E"/>
+                </a:solidFill>
+                <a:latin typeface="Georgia"/>
+              </a:rPr>
+              <a:t>Validação cruzada: o </a:t>
+            </a:r>
+            <a:r>
+              <a:rPr sz="1300" b="1" i="0">
+                <a:solidFill>
+                  <a:srgbClr val="17222E"/>
+                </a:solidFill>
+                <a:latin typeface="Georgia"/>
+              </a:rPr>
+              <a:t>GeoDa</a:t>
+            </a:r>
+            <a:r>
+              <a:rPr sz="1300" b="0" i="0">
+                <a:solidFill>
+                  <a:srgbClr val="17222E"/>
+                </a:solidFill>
+                <a:latin typeface="Georgia"/>
+              </a:rPr>
+              <a:t> reproduziu os índices (I = 0,832 / 0,426 / 0,183; p = 0,001) e a geografia dos clusters.</a:t>
             </a:r>
           </a:p>
         </p:txBody>

</xml_diff>

<commit_message>
feat: prints do GeoDa no repo e slide de validação na apresentação
- docs/geoda_prints/: 22 prints do experimento com nomes descritivos
  (mapas do passo 1, matriz de pesos, Moran, randomization e LISA)
- guia_geoda.md referencia os prints e avisa da compressão do WhatsApp
- slide novo 'Validação: GeoDa' com o diagrama de Moran e o LISA do roubo
- revisão de estilo nos textos dos slides (sem travessões e setas)
</commit_message>
<xml_diff>
--- a/slides/apresentacao.pptx
+++ b/slides/apresentacao.pptx
@@ -15,6 +15,7 @@
     <p:sldId id="263" r:id="rId14"/>
     <p:sldId id="264" r:id="rId15"/>
     <p:sldId id="265" r:id="rId16"/>
+    <p:sldId id="266" r:id="rId17"/>
   </p:sldIdLst>
   <p:sldSz cx="12191695" cy="6858000" type="screen4x3"/>
   <p:notesSz cx="6858000" cy="9144000"/>
@@ -3220,7 +3221,7 @@
                 </a:solidFill>
                 <a:latin typeface="Georgia"/>
               </a:rPr>
-              <a:t>Correlação e autocorrelação espacial das taxas de roubo, furto e lesão corporal nos municípios de São Paulo — resultados parciais.</a:t>
+              <a:t>Correlação e autocorrelação espacial das taxas de roubo, furto e lesão corporal nos municípios de São Paulo: resultados parciais.</a:t>
             </a:r>
           </a:p>
         </p:txBody>
@@ -3532,7 +3533,7 @@
                 </a:solidFill>
                 <a:latin typeface="Arial Narrow"/>
               </a:rPr>
-              <a:t>CONCLUSÕES PARCIAIS   </a:t>
+              <a:t>RESULTADOS · MAPAS COROPLÉTICOS   </a:t>
             </a:r>
           </a:p>
         </p:txBody>
@@ -3654,7 +3655,7 @@
                 </a:solidFill>
                 <a:latin typeface="Arial Narrow"/>
               </a:rPr>
-              <a:t>Onde estamos e </a:t>
+              <a:t>A faixa litorânea salta do mapa </a:t>
             </a:r>
             <a:r>
               <a:rPr sz="3400" b="1" i="0">
@@ -3663,21 +3664,45 @@
                 </a:solidFill>
                 <a:latin typeface="Arial Narrow"/>
               </a:rPr>
-              <a:t>para onde vamos</a:t>
-            </a:r>
-          </a:p>
-        </p:txBody>
-      </p:sp>
-      <p:sp>
-        <p:nvSpPr>
-          <p:cNvPr id="6" name="TextBox 5"/>
+              <a:t>no furto</a:t>
+            </a:r>
+          </a:p>
+        </p:txBody>
+      </p:sp>
+      <p:pic>
+        <p:nvPicPr>
+          <p:cNvPr id="6" name="Picture 5" descr="mapa_taxa_furto.png"/>
+          <p:cNvPicPr>
+            <a:picLocks noChangeAspect="1"/>
+          </p:cNvPicPr>
+          <p:nvPr/>
+        </p:nvPicPr>
+        <p:blipFill>
+          <a:blip r:embed="rId2"/>
+          <a:stretch>
+            <a:fillRect/>
+          </a:stretch>
+        </p:blipFill>
+        <p:spPr>
+          <a:xfrm>
+            <a:off x="822960" y="1783080"/>
+            <a:ext cx="4937760" cy="4389120"/>
+          </a:xfrm>
+          <a:prstGeom prst="rect">
+            <a:avLst/>
+          </a:prstGeom>
+        </p:spPr>
+      </p:pic>
+      <p:sp>
+        <p:nvSpPr>
+          <p:cNvPr id="7" name="TextBox 6"/>
           <p:cNvSpPr txBox="1"/>
           <p:nvPr/>
         </p:nvSpPr>
         <p:spPr>
           <a:xfrm>
-            <a:off x="822960" y="1828800"/>
-            <a:ext cx="9875520" cy="2468880"/>
+            <a:off x="822960" y="6172200"/>
+            <a:ext cx="5394960" cy="457200"/>
           </a:xfrm>
           <a:prstGeom prst="rect">
             <a:avLst/>
@@ -3696,75 +3721,89 @@
               </a:spcBef>
             </a:pPr>
             <a:r>
-              <a:rPr sz="1200" b="0" i="0">
-                <a:solidFill>
-                  <a:srgbClr val="0B5394"/>
-                </a:solidFill>
-                <a:latin typeface="Arial Narrow"/>
-              </a:rPr>
-              <a:t>■  </a:t>
-            </a:r>
-            <a:r>
-              <a:rPr sz="1500" b="1" i="0">
-                <a:solidFill>
-                  <a:srgbClr val="17222E"/>
-                </a:solidFill>
-                <a:latin typeface="Georgia"/>
-              </a:rPr>
-              <a:t>H1 (renda) não se sustenta até aqui</a:t>
-            </a:r>
-            <a:r>
-              <a:rPr sz="1500" b="0" i="0">
-                <a:solidFill>
-                  <a:srgbClr val="17222E"/>
-                </a:solidFill>
-                <a:latin typeface="Georgia"/>
-              </a:rPr>
-              <a:t>: a correlação entre renda e crimes patrimoniais é positiva; só a lesão corporal tem sinal fraco na direção esperada.</a:t>
-            </a:r>
-          </a:p>
+              <a:rPr sz="1100" b="0" i="0">
+                <a:solidFill>
+                  <a:srgbClr val="5B6B7C"/>
+                </a:solidFill>
+                <a:latin typeface="Georgia"/>
+              </a:rPr>
+              <a:t>Taxa de furto por 1.000 hab., classes por quintis. Máximo: Mongaguá, 34,2.</a:t>
+            </a:r>
+          </a:p>
+        </p:txBody>
+      </p:sp>
+      <p:sp>
+        <p:nvSpPr>
+          <p:cNvPr id="8" name="TextBox 7"/>
+          <p:cNvSpPr txBox="1"/>
+          <p:nvPr/>
+        </p:nvSpPr>
+        <p:spPr>
+          <a:xfrm>
+            <a:off x="6309360" y="2103120"/>
+            <a:ext cx="5120640" cy="3840480"/>
+          </a:xfrm>
+          <a:prstGeom prst="rect">
+            <a:avLst/>
+          </a:prstGeom>
+          <a:noFill/>
+        </p:spPr>
+        <p:txBody>
+          <a:bodyPr wrap="square">
+            <a:spAutoFit/>
+          </a:bodyPr>
+          <a:lstStyle/>
           <a:p>
             <a:pPr algn="l">
               <a:spcBef>
-                <a:spcPts val="1200"/>
+                <a:spcPts val="0"/>
               </a:spcBef>
             </a:pPr>
             <a:r>
-              <a:rPr sz="1200" b="0" i="0">
-                <a:solidFill>
-                  <a:srgbClr val="B2182B"/>
+              <a:rPr sz="1100" b="0" i="0">
+                <a:solidFill>
+                  <a:srgbClr val="0B5394"/>
                 </a:solidFill>
                 <a:latin typeface="Arial Narrow"/>
               </a:rPr>
               <a:t>■  </a:t>
             </a:r>
             <a:r>
-              <a:rPr sz="1500" b="1" i="0">
-                <a:solidFill>
-                  <a:srgbClr val="17222E"/>
-                </a:solidFill>
-                <a:latin typeface="Georgia"/>
-              </a:rPr>
-              <a:t>H2 (litoral/turismo) acumula evidência</a:t>
-            </a:r>
-            <a:r>
-              <a:rPr sz="1500" b="0" i="0">
-                <a:solidFill>
-                  <a:srgbClr val="17222E"/>
-                </a:solidFill>
-                <a:latin typeface="Georgia"/>
-              </a:rPr>
-              <a:t>: top 5 de furto, médias por grupo e cluster LISA litorâneo apontam na mesma direção.</a:t>
+              <a:rPr sz="1400" b="0" i="0">
+                <a:solidFill>
+                  <a:srgbClr val="17222E"/>
+                </a:solidFill>
+                <a:latin typeface="Georgia"/>
+              </a:rPr>
+              <a:t>Todo o litoral no </a:t>
+            </a:r>
+            <a:r>
+              <a:rPr sz="1400" b="1" i="0">
+                <a:solidFill>
+                  <a:srgbClr val="17222E"/>
+                </a:solidFill>
+                <a:latin typeface="Georgia"/>
+              </a:rPr>
+              <a:t>quintil superior</a:t>
+            </a:r>
+            <a:r>
+              <a:rPr sz="1400" b="0" i="0">
+                <a:solidFill>
+                  <a:srgbClr val="17222E"/>
+                </a:solidFill>
+                <a:latin typeface="Georgia"/>
+              </a:rPr>
+              <a:t> (azul escuro), junto com a macrometrópole e eixos do interior.</a:t>
             </a:r>
           </a:p>
           <a:p>
             <a:pPr algn="l">
               <a:spcBef>
-                <a:spcPts val="1200"/>
+                <a:spcPts val="1400"/>
               </a:spcBef>
             </a:pPr>
             <a:r>
-              <a:rPr sz="1200" b="0" i="0">
+              <a:rPr sz="1100" b="0" i="0">
                 <a:solidFill>
                   <a:srgbClr val="0B5394"/>
                 </a:solidFill>
@@ -3773,41 +3812,41 @@
               <a:t>■  </a:t>
             </a:r>
             <a:r>
-              <a:rPr sz="1500" b="0" i="0">
-                <a:solidFill>
-                  <a:srgbClr val="17222E"/>
-                </a:solidFill>
-                <a:latin typeface="Georgia"/>
-              </a:rPr>
-              <a:t>As taxas usam </a:t>
-            </a:r>
-            <a:r>
-              <a:rPr sz="1500" b="1" i="0">
-                <a:solidFill>
-                  <a:srgbClr val="17222E"/>
-                </a:solidFill>
-                <a:latin typeface="Georgia"/>
-              </a:rPr>
-              <a:t>população residente</a:t>
-            </a:r>
-            <a:r>
-              <a:rPr sz="1500" b="0" i="0">
-                <a:solidFill>
-                  <a:srgbClr val="17222E"/>
-                </a:solidFill>
-                <a:latin typeface="Georgia"/>
-              </a:rPr>
-              <a:t> — em cidades turísticas isso superestima o risco real. É limitação central a discutir no texto final.</a:t>
+              <a:rPr sz="1400" b="0" i="0">
+                <a:solidFill>
+                  <a:srgbClr val="17222E"/>
+                </a:solidFill>
+                <a:latin typeface="Georgia"/>
+              </a:rPr>
+              <a:t>O mesmo padrão não aparece na lesão corporal, o que reforça que o efeito vem dos </a:t>
+            </a:r>
+            <a:r>
+              <a:rPr sz="1400" b="1" i="0">
+                <a:solidFill>
+                  <a:srgbClr val="17222E"/>
+                </a:solidFill>
+                <a:latin typeface="Georgia"/>
+              </a:rPr>
+              <a:t>fluxos turísticos sobre crimes patrimoniais</a:t>
+            </a:r>
+            <a:r>
+              <a:rPr sz="1400" b="0" i="0">
+                <a:solidFill>
+                  <a:srgbClr val="17222E"/>
+                </a:solidFill>
+                <a:latin typeface="Georgia"/>
+              </a:rPr>
+              <a:t>, não de violência em geral.</a:t>
             </a:r>
           </a:p>
           <a:p>
             <a:pPr algn="l">
               <a:spcBef>
-                <a:spcPts val="1200"/>
+                <a:spcPts val="1400"/>
               </a:spcBef>
             </a:pPr>
             <a:r>
-              <a:rPr sz="1200" b="0" i="0">
+              <a:rPr sz="1100" b="0" i="0">
                 <a:solidFill>
                   <a:srgbClr val="0B5394"/>
                 </a:solidFill>
@@ -3816,42 +3855,90 @@
               <a:t>■  </a:t>
             </a:r>
             <a:r>
-              <a:rPr sz="1500" b="1" i="0">
-                <a:solidFill>
-                  <a:srgbClr val="17222E"/>
-                </a:solidFill>
-                <a:latin typeface="Georgia"/>
-              </a:rPr>
-              <a:t>Experimentos no GeoDa concluídos e validados</a:t>
-            </a:r>
-            <a:r>
-              <a:rPr sz="1500" b="0" i="0">
-                <a:solidFill>
-                  <a:srgbClr val="17222E"/>
-                </a:solidFill>
-                <a:latin typeface="Georgia"/>
-              </a:rPr>
-              <a:t> contra o pipeline em R (mapas, Moran global e LISA) — ver docs/guia_geoda.md.</a:t>
-            </a:r>
-          </a:p>
-        </p:txBody>
-      </p:sp>
-      <p:sp>
-        <p:nvSpPr>
-          <p:cNvPr id="7" name="Rectangle 6"/>
+              <a:rPr sz="1400" b="0" i="0">
+                <a:solidFill>
+                  <a:srgbClr val="17222E"/>
+                </a:solidFill>
+                <a:latin typeface="Georgia"/>
+              </a:rPr>
+              <a:t>Mapas equivalentes para roubo e lesão corporal em outputs/, gerados pelo mesmo pipeline.</a:t>
+            </a:r>
+          </a:p>
+        </p:txBody>
+      </p:sp>
+    </p:spTree>
+  </p:cSld>
+  <p:clrMapOvr>
+    <a:masterClrMapping/>
+  </p:clrMapOvr>
+</p:sld>
+</file>
+
+<file path=ppt/slides/slide11.xml><?xml version="1.0" encoding="utf-8"?>
+<p:sld xmlns:a="http://schemas.openxmlformats.org/drawingml/2006/main" xmlns:p="http://schemas.openxmlformats.org/presentationml/2006/main" xmlns:r="http://schemas.openxmlformats.org/officeDocument/2006/relationships">
+  <p:cSld>
+    <p:spTree>
+      <p:nvGrpSpPr>
+        <p:cNvPr id="1" name=""/>
+        <p:cNvGrpSpPr/>
+        <p:nvPr/>
+      </p:nvGrpSpPr>
+      <p:grpSpPr/>
+      <p:sp>
+        <p:nvSpPr>
+          <p:cNvPr id="2" name="TextBox 1"/>
+          <p:cNvSpPr txBox="1"/>
+          <p:nvPr/>
+        </p:nvSpPr>
+        <p:spPr>
+          <a:xfrm>
+            <a:off x="822960" y="384048"/>
+            <a:ext cx="10543032" cy="365760"/>
+          </a:xfrm>
+          <a:prstGeom prst="rect">
+            <a:avLst/>
+          </a:prstGeom>
+          <a:noFill/>
+        </p:spPr>
+        <p:txBody>
+          <a:bodyPr wrap="square">
+            <a:spAutoFit/>
+          </a:bodyPr>
+          <a:lstStyle/>
+          <a:p>
+            <a:pPr algn="l">
+              <a:spcBef>
+                <a:spcPts val="0"/>
+              </a:spcBef>
+            </a:pPr>
+            <a:r>
+              <a:rPr sz="1300" b="1" i="0">
+                <a:solidFill>
+                  <a:srgbClr val="0B5394"/>
+                </a:solidFill>
+                <a:latin typeface="Arial Narrow"/>
+              </a:rPr>
+              <a:t>CONCLUSÕES PARCIAIS   </a:t>
+            </a:r>
+          </a:p>
+        </p:txBody>
+      </p:sp>
+      <p:sp>
+        <p:nvSpPr>
+          <p:cNvPr id="3" name="Rectangle 2"/>
           <p:cNvSpPr/>
           <p:nvPr/>
         </p:nvSpPr>
         <p:spPr>
           <a:xfrm>
-            <a:off x="822960" y="4297680"/>
-            <a:ext cx="50800" cy="1143000"/>
+            <a:off x="822960" y="749808"/>
+            <a:ext cx="10543032" cy="15240"/>
           </a:xfrm>
           <a:prstGeom prst="rect">
             <a:avLst/>
           </a:prstGeom>
           <a:solidFill>
-            <a:srgbClr val="0B5394"/>
+            <a:srgbClr val="D8DFE7"/>
           </a:solidFill>
           <a:ln>
             <a:noFill/>
@@ -3882,20 +3969,275 @@
       </p:sp>
       <p:sp>
         <p:nvSpPr>
-          <p:cNvPr id="8" name="Rectangle 7"/>
+          <p:cNvPr id="4" name="TextBox 3"/>
+          <p:cNvSpPr txBox="1"/>
+          <p:nvPr/>
+        </p:nvSpPr>
+        <p:spPr>
+          <a:xfrm>
+            <a:off x="10607040" y="384048"/>
+            <a:ext cx="758952" cy="365760"/>
+          </a:xfrm>
+          <a:prstGeom prst="rect">
+            <a:avLst/>
+          </a:prstGeom>
+          <a:noFill/>
+        </p:spPr>
+        <p:txBody>
+          <a:bodyPr wrap="square">
+            <a:spAutoFit/>
+          </a:bodyPr>
+          <a:lstStyle/>
+          <a:p>
+            <a:pPr algn="r">
+              <a:spcBef>
+                <a:spcPts val="0"/>
+              </a:spcBef>
+            </a:pPr>
+            <a:r>
+              <a:rPr sz="1300" b="0" i="0">
+                <a:solidFill>
+                  <a:srgbClr val="5B6B7C"/>
+                </a:solidFill>
+                <a:latin typeface="Arial Narrow"/>
+              </a:rPr>
+              <a:t>11</a:t>
+            </a:r>
+          </a:p>
+        </p:txBody>
+      </p:sp>
+      <p:sp>
+        <p:nvSpPr>
+          <p:cNvPr id="5" name="TextBox 4"/>
+          <p:cNvSpPr txBox="1"/>
+          <p:nvPr/>
+        </p:nvSpPr>
+        <p:spPr>
+          <a:xfrm>
+            <a:off x="822960" y="960120"/>
+            <a:ext cx="10543032" cy="822960"/>
+          </a:xfrm>
+          <a:prstGeom prst="rect">
+            <a:avLst/>
+          </a:prstGeom>
+          <a:noFill/>
+        </p:spPr>
+        <p:txBody>
+          <a:bodyPr wrap="square">
+            <a:spAutoFit/>
+          </a:bodyPr>
+          <a:lstStyle/>
+          <a:p>
+            <a:pPr algn="l">
+              <a:spcBef>
+                <a:spcPts val="0"/>
+              </a:spcBef>
+            </a:pPr>
+            <a:r>
+              <a:rPr sz="3400" b="1" i="0">
+                <a:solidFill>
+                  <a:srgbClr val="17222E"/>
+                </a:solidFill>
+                <a:latin typeface="Arial Narrow"/>
+              </a:rPr>
+              <a:t>Onde estamos e </a:t>
+            </a:r>
+            <a:r>
+              <a:rPr sz="3400" b="1" i="0">
+                <a:solidFill>
+                  <a:srgbClr val="0B5394"/>
+                </a:solidFill>
+                <a:latin typeface="Arial Narrow"/>
+              </a:rPr>
+              <a:t>para onde vamos</a:t>
+            </a:r>
+          </a:p>
+        </p:txBody>
+      </p:sp>
+      <p:sp>
+        <p:nvSpPr>
+          <p:cNvPr id="6" name="TextBox 5"/>
+          <p:cNvSpPr txBox="1"/>
+          <p:nvPr/>
+        </p:nvSpPr>
+        <p:spPr>
+          <a:xfrm>
+            <a:off x="822960" y="1828800"/>
+            <a:ext cx="9875520" cy="2468880"/>
+          </a:xfrm>
+          <a:prstGeom prst="rect">
+            <a:avLst/>
+          </a:prstGeom>
+          <a:noFill/>
+        </p:spPr>
+        <p:txBody>
+          <a:bodyPr wrap="square">
+            <a:spAutoFit/>
+          </a:bodyPr>
+          <a:lstStyle/>
+          <a:p>
+            <a:pPr algn="l">
+              <a:spcBef>
+                <a:spcPts val="0"/>
+              </a:spcBef>
+            </a:pPr>
+            <a:r>
+              <a:rPr sz="1200" b="0" i="0">
+                <a:solidFill>
+                  <a:srgbClr val="0B5394"/>
+                </a:solidFill>
+                <a:latin typeface="Arial Narrow"/>
+              </a:rPr>
+              <a:t>■  </a:t>
+            </a:r>
+            <a:r>
+              <a:rPr sz="1500" b="1" i="0">
+                <a:solidFill>
+                  <a:srgbClr val="17222E"/>
+                </a:solidFill>
+                <a:latin typeface="Georgia"/>
+              </a:rPr>
+              <a:t>H1 (renda) não se sustenta até aqui</a:t>
+            </a:r>
+            <a:r>
+              <a:rPr sz="1500" b="0" i="0">
+                <a:solidFill>
+                  <a:srgbClr val="17222E"/>
+                </a:solidFill>
+                <a:latin typeface="Georgia"/>
+              </a:rPr>
+              <a:t>: a correlação entre renda e crimes patrimoniais é positiva; só a lesão corporal tem sinal fraco na direção esperada.</a:t>
+            </a:r>
+          </a:p>
+          <a:p>
+            <a:pPr algn="l">
+              <a:spcBef>
+                <a:spcPts val="1200"/>
+              </a:spcBef>
+            </a:pPr>
+            <a:r>
+              <a:rPr sz="1200" b="0" i="0">
+                <a:solidFill>
+                  <a:srgbClr val="B2182B"/>
+                </a:solidFill>
+                <a:latin typeface="Arial Narrow"/>
+              </a:rPr>
+              <a:t>■  </a:t>
+            </a:r>
+            <a:r>
+              <a:rPr sz="1500" b="1" i="0">
+                <a:solidFill>
+                  <a:srgbClr val="17222E"/>
+                </a:solidFill>
+                <a:latin typeface="Georgia"/>
+              </a:rPr>
+              <a:t>H2 (litoral/turismo) acumula evidência</a:t>
+            </a:r>
+            <a:r>
+              <a:rPr sz="1500" b="0" i="0">
+                <a:solidFill>
+                  <a:srgbClr val="17222E"/>
+                </a:solidFill>
+                <a:latin typeface="Georgia"/>
+              </a:rPr>
+              <a:t>: top 5 de furto, médias por grupo e cluster LISA litorâneo apontam na mesma direção.</a:t>
+            </a:r>
+          </a:p>
+          <a:p>
+            <a:pPr algn="l">
+              <a:spcBef>
+                <a:spcPts val="1200"/>
+              </a:spcBef>
+            </a:pPr>
+            <a:r>
+              <a:rPr sz="1200" b="0" i="0">
+                <a:solidFill>
+                  <a:srgbClr val="0B5394"/>
+                </a:solidFill>
+                <a:latin typeface="Arial Narrow"/>
+              </a:rPr>
+              <a:t>■  </a:t>
+            </a:r>
+            <a:r>
+              <a:rPr sz="1500" b="0" i="0">
+                <a:solidFill>
+                  <a:srgbClr val="17222E"/>
+                </a:solidFill>
+                <a:latin typeface="Georgia"/>
+              </a:rPr>
+              <a:t>As taxas usam </a:t>
+            </a:r>
+            <a:r>
+              <a:rPr sz="1500" b="1" i="0">
+                <a:solidFill>
+                  <a:srgbClr val="17222E"/>
+                </a:solidFill>
+                <a:latin typeface="Georgia"/>
+              </a:rPr>
+              <a:t>população residente</a:t>
+            </a:r>
+            <a:r>
+              <a:rPr sz="1500" b="0" i="0">
+                <a:solidFill>
+                  <a:srgbClr val="17222E"/>
+                </a:solidFill>
+                <a:latin typeface="Georgia"/>
+              </a:rPr>
+              <a:t>; em cidades turísticas isso superestima o risco real, limitação central a discutir no texto final.</a:t>
+            </a:r>
+          </a:p>
+          <a:p>
+            <a:pPr algn="l">
+              <a:spcBef>
+                <a:spcPts val="1200"/>
+              </a:spcBef>
+            </a:pPr>
+            <a:r>
+              <a:rPr sz="1200" b="0" i="0">
+                <a:solidFill>
+                  <a:srgbClr val="0B5394"/>
+                </a:solidFill>
+                <a:latin typeface="Arial Narrow"/>
+              </a:rPr>
+              <a:t>■  </a:t>
+            </a:r>
+            <a:r>
+              <a:rPr sz="1500" b="1" i="0">
+                <a:solidFill>
+                  <a:srgbClr val="17222E"/>
+                </a:solidFill>
+                <a:latin typeface="Georgia"/>
+              </a:rPr>
+              <a:t>Experimentos no GeoDa concluídos e validados</a:t>
+            </a:r>
+            <a:r>
+              <a:rPr sz="1500" b="0" i="0">
+                <a:solidFill>
+                  <a:srgbClr val="17222E"/>
+                </a:solidFill>
+                <a:latin typeface="Georgia"/>
+              </a:rPr>
+              <a:t> contra o pipeline em R (mapas, Moran global e LISA); roteiro e resultados em docs/guia_geoda.md.</a:t>
+            </a:r>
+          </a:p>
+        </p:txBody>
+      </p:sp>
+      <p:sp>
+        <p:nvSpPr>
+          <p:cNvPr id="7" name="Rectangle 6"/>
           <p:cNvSpPr/>
           <p:nvPr/>
         </p:nvSpPr>
         <p:spPr>
           <a:xfrm>
-            <a:off x="873760" y="4297680"/>
-            <a:ext cx="9824720" cy="1143000"/>
+            <a:off x="822960" y="4297680"/>
+            <a:ext cx="50800" cy="1143000"/>
           </a:xfrm>
           <a:prstGeom prst="rect">
             <a:avLst/>
           </a:prstGeom>
           <a:solidFill>
-            <a:srgbClr val="F0F4F9"/>
+            <a:srgbClr val="0B5394"/>
           </a:solidFill>
           <a:ln>
             <a:noFill/>
@@ -3917,6 +4259,50 @@
           </a:fontRef>
         </p:style>
         <p:txBody>
+          <a:bodyPr rtlCol="0" anchor="ctr"/>
+          <a:lstStyle/>
+          <a:p>
+            <a:pPr algn="ctr"/>
+          </a:p>
+        </p:txBody>
+      </p:sp>
+      <p:sp>
+        <p:nvSpPr>
+          <p:cNvPr id="8" name="Rectangle 7"/>
+          <p:cNvSpPr/>
+          <p:nvPr/>
+        </p:nvSpPr>
+        <p:spPr>
+          <a:xfrm>
+            <a:off x="873760" y="4297680"/>
+            <a:ext cx="9824720" cy="1143000"/>
+          </a:xfrm>
+          <a:prstGeom prst="rect">
+            <a:avLst/>
+          </a:prstGeom>
+          <a:solidFill>
+            <a:srgbClr val="F0F4F9"/>
+          </a:solidFill>
+          <a:ln>
+            <a:noFill/>
+          </a:ln>
+          <a:effectLst/>
+        </p:spPr>
+        <p:style>
+          <a:lnRef idx="1">
+            <a:schemeClr val="accent1"/>
+          </a:lnRef>
+          <a:fillRef idx="3">
+            <a:schemeClr val="accent1"/>
+          </a:fillRef>
+          <a:effectRef idx="2">
+            <a:schemeClr val="accent1"/>
+          </a:effectRef>
+          <a:fontRef idx="minor">
+            <a:schemeClr val="lt1"/>
+          </a:fontRef>
+        </p:style>
+        <p:txBody>
           <a:bodyPr rtlCol="0" anchor="t" wrap="square" lIns="164592" rIns="137160" tIns="91440" bIns="91440"/>
           <a:lstStyle/>
           <a:p>
@@ -3948,7 +4334,7 @@
                 </a:solidFill>
                 <a:latin typeface="Georgia"/>
               </a:rPr>
-              <a:t>1 · Revisar a classificação litorânea/turística (incluir estâncias do interior?)   2 · Testar denominadores com população flutuante   3 · Regressão espacial com renda + dummy   4 · Fechar o relatório final.</a:t>
+              <a:t>1) Revisar a classificação litorânea/turística (incluir estâncias do interior?); 2) testar denominadores com população flutuante; 3) regressão espacial com renda e a dummy; 4) fechar o relatório final.</a:t>
             </a:r>
           </a:p>
         </p:txBody>
@@ -4319,7 +4705,7 @@
                 </a:solidFill>
                 <a:latin typeface="Georgia"/>
               </a:rPr>
-              <a:t>“Acontecem mais crimes nas cidades mais pobres?” — cruzamos as ocorrências criminais da SSP-SP com a renda média do Censo 2022.</a:t>
+              <a:t>“Acontecem mais crimes nas cidades mais pobres?” Para responder, cruzamos as ocorrências criminais da SSP-SP com a renda média do Censo 2022.</a:t>
             </a:r>
           </a:p>
         </p:txBody>
@@ -4489,7 +4875,7 @@
                 </a:solidFill>
                 <a:latin typeface="Georgia"/>
               </a:rPr>
-              <a:t> infla as ocorrências, enquanto o denominador conta apenas residentes → a análise precisava virar </a:t>
+              <a:t> infla as ocorrências, enquanto o denominador conta apenas residentes. Daí a necessidade de uma análise </a:t>
             </a:r>
             <a:r>
               <a:rPr sz="1600" b="1" i="0">
@@ -4902,7 +5288,7 @@
                           </a:solidFill>
                           <a:latin typeface="Georgia"/>
                         </a:rPr>
-                        <a:t>IBGE — Censo 2022</a:t>
+                        <a:t>IBGE, Censo 2022</a:t>
                       </a:r>
                     </a:p>
                   </a:txBody>
@@ -4973,7 +5359,7 @@
                           </a:solidFill>
                           <a:latin typeface="Georgia"/>
                         </a:rPr>
-                        <a:t>IBGE — Tabela 4709</a:t>
+                        <a:t>IBGE, Tabela 4709</a:t>
                       </a:r>
                     </a:p>
                   </a:txBody>
@@ -5168,7 +5554,7 @@
                 </a:solidFill>
                 <a:latin typeface="Georgia"/>
               </a:rPr>
-              <a:t>Validação automática: chave única, tipos, NAs — e </a:t>
+              <a:t>Validação automática: chave única, tipos e NAs, com </a:t>
             </a:r>
             <a:r>
               <a:rPr sz="1500" b="1" i="0">
@@ -5186,7 +5572,7 @@
                 </a:solidFill>
                 <a:latin typeface="Georgia"/>
               </a:rPr>
-              <a:t> no pareamento de nomes SSP ↔ IBGE (abreviações como “S BARBARA D OESTE”).</a:t>
+              <a:t> no pareamento de nomes da SSP com o IBGE (abreviações como “S BARBARA D OESTE”).</a:t>
             </a:r>
           </a:p>
         </p:txBody>
@@ -5509,7 +5895,7 @@
                 </a:solidFill>
                 <a:latin typeface="Georgia"/>
               </a:rPr>
-              <a:t> concentram taxas de crime mais altas — esperaríamos correlação </a:t>
+              <a:t> concentram taxas de crime mais altas; a correlação esperada entre renda e taxas seria </a:t>
             </a:r>
             <a:r>
               <a:rPr sz="1400" b="1" i="0">
@@ -5527,7 +5913,7 @@
                 </a:solidFill>
                 <a:latin typeface="Georgia"/>
               </a:rPr>
-              <a:t> entre renda e taxas.</a:t>
+              <a:t>.</a:t>
             </a:r>
           </a:p>
         </p:txBody>
@@ -5710,7 +6096,7 @@
                 </a:solidFill>
                 <a:latin typeface="Georgia"/>
               </a:rPr>
-              <a:t>Para testar H2 criamos a dummy litoranea_turistica — default: os </a:t>
+              <a:t>Para testar H2 criamos a dummy litoranea_turistica (default: os </a:t>
             </a:r>
             <a:r>
               <a:rPr sz="1500" b="1" i="0">
@@ -5728,7 +6114,7 @@
                 </a:solidFill>
                 <a:latin typeface="Georgia"/>
               </a:rPr>
-              <a:t>, em arquivo editável (data/litoranea_turistica.csv) para revisão do grupo.</a:t>
+              <a:t>), em arquivo editável (data/litoranea_turistica.csv) para revisão do grupo.</a:t>
             </a:r>
           </a:p>
         </p:txBody>
@@ -5964,7 +6350,7 @@
                 </a:solidFill>
                 <a:latin typeface="Georgia"/>
               </a:rPr>
-              <a:t>   —   R com sf · spdep · geobr · ggplot2 · corrplot</a:t>
+              <a:t>   em R com sf, spdep, geobr, ggplot2 e corrplot</a:t>
             </a:r>
           </a:p>
         </p:txBody>
@@ -6157,7 +6543,7 @@
                 </a:solidFill>
                 <a:latin typeface="Georgia"/>
               </a:rPr>
-              <a:t> — vizinhança queen</a:t>
+              <a:t>, vizinhança queen</a:t>
             </a:r>
           </a:p>
           <a:p>
@@ -6225,7 +6611,7 @@
                 </a:solidFill>
                 <a:latin typeface="Georgia"/>
               </a:rPr>
-              <a:t> em Markdown + xlsx com todas as tabelas</a:t>
+              <a:t> em Markdown e xlsx com todas as tabelas</a:t>
             </a:r>
           </a:p>
         </p:txBody>
@@ -7062,7 +7448,7 @@
                 </a:solidFill>
                 <a:latin typeface="Georgia"/>
               </a:rPr>
-              <a:t>municípios litorâneos/turísticos. Lesão corporal foge ao padrão: topo dominado por municípios pequenos do interior (Balbinos 14,2 — pop. 3.887).</a:t>
+              <a:t>municípios litorâneos/turísticos. Lesão corporal foge ao padrão: topo dominado por municípios pequenos do interior (Balbinos: 14,2, com 3.887 habitantes).</a:t>
             </a:r>
           </a:p>
         </p:txBody>
@@ -7519,7 +7905,7 @@
                 </a:solidFill>
                 <a:latin typeface="Georgia"/>
               </a:rPr>
-              <a:t> — com renda praticamente igual à média estadual.</a:t>
+              <a:t>, com renda praticamente igual à média estadual.</a:t>
             </a:r>
           </a:p>
         </p:txBody>
@@ -7806,7 +8192,7 @@
                 </a:solidFill>
                 <a:latin typeface="Georgia"/>
               </a:rPr>
-              <a:t> — os crimes patrimoniais andam juntos no território.</a:t>
+              <a:t>: os crimes patrimoniais andam juntos no território.</a:t>
             </a:r>
           </a:p>
           <a:p>
@@ -7867,7 +8253,7 @@
                 </a:solidFill>
                 <a:latin typeface="Georgia"/>
               </a:rPr>
-              <a:t> — sinal </a:t>
+              <a:t>, sinal </a:t>
             </a:r>
             <a:r>
               <a:rPr sz="1400" b="1" i="0">
@@ -7937,7 +8323,7 @@
                 </a:solidFill>
                 <a:latin typeface="Georgia"/>
               </a:rPr>
-              <a:t> — única taxa com sinal “esperado”, e fraco.</a:t>
+              <a:t>, a única taxa com o sinal “esperado”, e fraco.</a:t>
             </a:r>
           </a:p>
           <a:p>
@@ -8636,7 +9022,7 @@
                 </a:solidFill>
                 <a:latin typeface="Georgia"/>
               </a:rPr>
-              <a:t>: um único grande cluster Alto-Alto — </a:t>
+              <a:t>: um único grande cluster Alto-Alto na </a:t>
             </a:r>
             <a:r>
               <a:rPr sz="1300" b="1" i="0">
@@ -8645,7 +9031,7 @@
                 </a:solidFill>
                 <a:latin typeface="Georgia"/>
               </a:rPr>
-              <a:t>RMSP + Baixada Santista</a:t>
+              <a:t>RMSP e Baixada Santista</a:t>
             </a:r>
             <a:r>
               <a:rPr sz="1300" b="0" i="0">
@@ -8654,7 +9040,7 @@
                 </a:solidFill>
                 <a:latin typeface="Georgia"/>
               </a:rPr>
-              <a:t> (45 municípios) — e extenso campo Baixo-Baixo no oeste.</a:t>
+              <a:t> (45 municípios), além de um extenso campo Baixo-Baixo no oeste.</a:t>
             </a:r>
           </a:p>
           <a:p>
@@ -8706,7 +9092,7 @@
                 </a:solidFill>
                 <a:latin typeface="Georgia"/>
               </a:rPr>
-              <a:t> — 36% dos municípios do cluster são litorâneos/turísticos. </a:t>
+              <a:t>: 36% dos municípios do cluster são litorâneos/turísticos. </a:t>
             </a:r>
             <a:r>
               <a:rPr sz="1300" b="1" i="0">
@@ -8821,7 +9207,7 @@
                 </a:solidFill>
                 <a:latin typeface="Georgia"/>
               </a:rPr>
-              <a:t>LISA — roubo. Vermelho: municípios de taxa alta cercados por vizinhos de taxa alta (p ≤ 0,05).</a:t>
+              <a:t>LISA do roubo. Vermelho: municípios de taxa alta cercados por vizinhos de taxa alta (p ≤ 0,05).</a:t>
             </a:r>
           </a:p>
         </p:txBody>
@@ -8878,7 +9264,7 @@
                 </a:solidFill>
                 <a:latin typeface="Arial Narrow"/>
               </a:rPr>
-              <a:t>RESULTADOS · MAPAS COROPLÉTICOS   </a:t>
+              <a:t>VALIDAÇÃO · GEODA   </a:t>
             </a:r>
           </a:p>
         </p:txBody>
@@ -9000,7 +9386,7 @@
                 </a:solidFill>
                 <a:latin typeface="Arial Narrow"/>
               </a:rPr>
-              <a:t>A faixa litorânea salta do mapa </a:t>
+              <a:t>O experimento no GeoDa </a:t>
             </a:r>
             <a:r>
               <a:rPr sz="3400" b="1" i="0">
@@ -9009,14 +9395,14 @@
                 </a:solidFill>
                 <a:latin typeface="Arial Narrow"/>
               </a:rPr>
-              <a:t>no furto</a:t>
+              <a:t>reproduziu o pipeline</a:t>
             </a:r>
           </a:p>
         </p:txBody>
       </p:sp>
       <p:pic>
         <p:nvPicPr>
-          <p:cNvPr id="6" name="Picture 5" descr="mapa_taxa_furto.png"/>
+          <p:cNvPr id="6" name="Picture 5" descr="moran_tx_roubo.jpeg"/>
           <p:cNvPicPr>
             <a:picLocks noChangeAspect="1"/>
           </p:cNvPicPr>
@@ -9030,8 +9416,8 @@
         </p:blipFill>
         <p:spPr>
           <a:xfrm>
-            <a:off x="822960" y="1783080"/>
-            <a:ext cx="4937760" cy="4389120"/>
+            <a:off x="822960" y="1828800"/>
+            <a:ext cx="4846320" cy="3063643"/>
           </a:xfrm>
           <a:prstGeom prst="rect">
             <a:avLst/>
@@ -9046,8 +9432,8 @@
         </p:nvSpPr>
         <p:spPr>
           <a:xfrm>
-            <a:off x="822960" y="6172200"/>
-            <a:ext cx="5394960" cy="457200"/>
+            <a:off x="822960" y="4983480"/>
+            <a:ext cx="4846320" cy="777240"/>
           </a:xfrm>
           <a:prstGeom prst="rect">
             <a:avLst/>
@@ -9072,21 +9458,63 @@
                 </a:solidFill>
                 <a:latin typeface="Georgia"/>
               </a:rPr>
-              <a:t>Taxa de furto por 1.000 hab., classes por quintis. Máximo: Mongaguá, 34,2.</a:t>
-            </a:r>
-          </a:p>
-        </p:txBody>
-      </p:sp>
-      <p:sp>
-        <p:nvSpPr>
-          <p:cNvPr id="8" name="TextBox 7"/>
+              <a:t>Diagrama de Moran no GeoDa (tx_roubo): </a:t>
+            </a:r>
+            <a:r>
+              <a:rPr sz="1100" b="1" i="0">
+                <a:solidFill>
+                  <a:srgbClr val="17222E"/>
+                </a:solidFill>
+                <a:latin typeface="Georgia"/>
+              </a:rPr>
+              <a:t>I = 0,832</a:t>
+            </a:r>
+            <a:r>
+              <a:rPr sz="1100" b="0" i="0">
+                <a:solidFill>
+                  <a:srgbClr val="5B6B7C"/>
+                </a:solidFill>
+                <a:latin typeface="Georgia"/>
+              </a:rPr>
+              <a:t>, idêntico ao R (randomization: z = 35,6; pseudo p = 0,001).</a:t>
+            </a:r>
+          </a:p>
+        </p:txBody>
+      </p:sp>
+      <p:pic>
+        <p:nvPicPr>
+          <p:cNvPr id="8" name="Picture 7" descr="lisa_tx_roubo.jpeg"/>
+          <p:cNvPicPr>
+            <a:picLocks noChangeAspect="1"/>
+          </p:cNvPicPr>
+          <p:nvPr/>
+        </p:nvPicPr>
+        <p:blipFill>
+          <a:blip r:embed="rId3"/>
+          <a:stretch>
+            <a:fillRect/>
+          </a:stretch>
+        </p:blipFill>
+        <p:spPr>
+          <a:xfrm>
+            <a:off x="6035040" y="1828800"/>
+            <a:ext cx="5394960" cy="1801384"/>
+          </a:xfrm>
+          <a:prstGeom prst="rect">
+            <a:avLst/>
+          </a:prstGeom>
+        </p:spPr>
+      </p:pic>
+      <p:sp>
+        <p:nvSpPr>
+          <p:cNvPr id="9" name="TextBox 8"/>
           <p:cNvSpPr txBox="1"/>
           <p:nvPr/>
         </p:nvSpPr>
         <p:spPr>
           <a:xfrm>
-            <a:off x="6309360" y="2103120"/>
-            <a:ext cx="5120640" cy="3840480"/>
+            <a:off x="6035040" y="3794760"/>
+            <a:ext cx="5394960" cy="777240"/>
           </a:xfrm>
           <a:prstGeom prst="rect">
             <a:avLst/>
@@ -9107,48 +9535,44 @@
             <a:r>
               <a:rPr sz="1100" b="0" i="0">
                 <a:solidFill>
-                  <a:srgbClr val="0B5394"/>
-                </a:solidFill>
-                <a:latin typeface="Arial Narrow"/>
-              </a:rPr>
-              <a:t>■  </a:t>
-            </a:r>
-            <a:r>
-              <a:rPr sz="1400" b="0" i="0">
-                <a:solidFill>
-                  <a:srgbClr val="17222E"/>
-                </a:solidFill>
-                <a:latin typeface="Georgia"/>
-              </a:rPr>
-              <a:t>Todo o litoral no </a:t>
-            </a:r>
-            <a:r>
-              <a:rPr sz="1400" b="1" i="0">
-                <a:solidFill>
-                  <a:srgbClr val="17222E"/>
-                </a:solidFill>
-                <a:latin typeface="Georgia"/>
-              </a:rPr>
-              <a:t>quintil superior</a:t>
-            </a:r>
-            <a:r>
-              <a:rPr sz="1400" b="0" i="0">
-                <a:solidFill>
-                  <a:srgbClr val="17222E"/>
-                </a:solidFill>
-                <a:latin typeface="Georgia"/>
-              </a:rPr>
-              <a:t> (azul escuro), junto com a macrometrópole e eixos do interior.</a:t>
-            </a:r>
-          </a:p>
+                  <a:srgbClr val="5B6B7C"/>
+                </a:solidFill>
+                <a:latin typeface="Georgia"/>
+              </a:rPr>
+              <a:t>LISA no GeoDa (tx_roubo): mesmo cluster Alto-Alto (RMSP e Baixada) e campo Baixo-Baixo no oeste que o pipeline em R encontrou.</a:t>
+            </a:r>
+          </a:p>
+        </p:txBody>
+      </p:sp>
+      <p:sp>
+        <p:nvSpPr>
+          <p:cNvPr id="10" name="TextBox 9"/>
+          <p:cNvSpPr txBox="1"/>
+          <p:nvPr/>
+        </p:nvSpPr>
+        <p:spPr>
+          <a:xfrm>
+            <a:off x="822960" y="5806440"/>
+            <a:ext cx="10058400" cy="822960"/>
+          </a:xfrm>
+          <a:prstGeom prst="rect">
+            <a:avLst/>
+          </a:prstGeom>
+          <a:noFill/>
+        </p:spPr>
+        <p:txBody>
+          <a:bodyPr wrap="square">
+            <a:spAutoFit/>
+          </a:bodyPr>
+          <a:lstStyle/>
           <a:p>
             <a:pPr algn="l">
               <a:spcBef>
-                <a:spcPts val="1400"/>
+                <a:spcPts val="0"/>
               </a:spcBef>
             </a:pPr>
             <a:r>
-              <a:rPr sz="1100" b="0" i="0">
+              <a:rPr sz="1000" b="0" i="0">
                 <a:solidFill>
                   <a:srgbClr val="0B5394"/>
                 </a:solidFill>
@@ -9157,56 +9581,31 @@
               <a:t>■  </a:t>
             </a:r>
             <a:r>
-              <a:rPr sz="1400" b="0" i="0">
-                <a:solidFill>
-                  <a:srgbClr val="17222E"/>
-                </a:solidFill>
-                <a:latin typeface="Georgia"/>
-              </a:rPr>
-              <a:t>O mesmo padrão não aparece na lesão corporal — reforça que o efeito é dos </a:t>
-            </a:r>
-            <a:r>
-              <a:rPr sz="1400" b="1" i="0">
-                <a:solidFill>
-                  <a:srgbClr val="17222E"/>
-                </a:solidFill>
-                <a:latin typeface="Georgia"/>
-              </a:rPr>
-              <a:t>fluxos turísticos sobre crimes patrimoniais</a:t>
-            </a:r>
-            <a:r>
-              <a:rPr sz="1400" b="0" i="0">
-                <a:solidFill>
-                  <a:srgbClr val="17222E"/>
-                </a:solidFill>
-                <a:latin typeface="Georgia"/>
-              </a:rPr>
-              <a:t>, não de violência em geral.</a:t>
-            </a:r>
-          </a:p>
-          <a:p>
-            <a:pPr algn="l">
-              <a:spcBef>
-                <a:spcPts val="1400"/>
-              </a:spcBef>
-            </a:pPr>
-            <a:r>
-              <a:rPr sz="1100" b="0" i="0">
-                <a:solidFill>
-                  <a:srgbClr val="0B5394"/>
-                </a:solidFill>
-                <a:latin typeface="Arial Narrow"/>
-              </a:rPr>
-              <a:t>■  </a:t>
-            </a:r>
-            <a:r>
-              <a:rPr sz="1400" b="0" i="0">
-                <a:solidFill>
-                  <a:srgbClr val="17222E"/>
-                </a:solidFill>
-                <a:latin typeface="Georgia"/>
-              </a:rPr>
-              <a:t>Mapas equivalentes para roubo e lesão corporal em outputs/, gerados pelo mesmo pipeline.</a:t>
+              <a:rPr sz="1300" b="0" i="0">
+                <a:solidFill>
+                  <a:srgbClr val="17222E"/>
+                </a:solidFill>
+                <a:latin typeface="Georgia"/>
+              </a:rPr>
+              <a:t>Matriz queen ordem 1 conferida: mín. 0 (Ilhabela), máx. 22, média 5,50, </a:t>
+            </a:r>
+            <a:r>
+              <a:rPr sz="1300" b="1" i="0">
+                <a:solidFill>
+                  <a:srgbClr val="17222E"/>
+                </a:solidFill>
+                <a:latin typeface="Georgia"/>
+              </a:rPr>
+              <a:t>idêntica nos dois softwares</a:t>
+            </a:r>
+            <a:r>
+              <a:rPr sz="1300" b="0" i="0">
+                <a:solidFill>
+                  <a:srgbClr val="17222E"/>
+                </a:solidFill>
+                <a:latin typeface="Georgia"/>
+              </a:rPr>
+              <a:t>. Clusters Alto-Alto robustos ao método de inferência; prints completos em docs/geoda_prints/.</a:t>
             </a:r>
           </a:p>
         </p:txBody>

</xml_diff>